<commit_message>
docs(presentation): upgrade slide narrative for outstanding rubric criteria
</commit_message>
<xml_diff>
--- a/cfx-api/docs/presentation.pptx
+++ b/cfx-api/docs/presentation.pptx
@@ -17,6 +17,7 @@
     <p:sldId id="265" r:id="rId11"/>
     <p:sldId id="266" r:id="rId12"/>
     <p:sldId id="267" r:id="rId13"/>
+    <p:sldId id="268" r:id="rId14"/>
   </p:sldIdLst>
   <p:sldSz cx="9144000" cy="6858000" type="screen4x3"/>
   <p:notesSz cx="6858000" cy="9144000"/>
@@ -3230,7 +3231,39 @@
             </a:pPr>
             <a:r>
               <a:rPr/>
-              <a:t>Challenges</a:t>
+              <a:t>Live</a:t>
+            </a:r>
+            <a:r>
+              <a:rPr/>
+              <a:t> </a:t>
+            </a:r>
+            <a:r>
+              <a:rPr/>
+              <a:t>Demo</a:t>
+            </a:r>
+            <a:r>
+              <a:rPr/>
+              <a:t> </a:t>
+            </a:r>
+            <a:r>
+              <a:rPr/>
+              <a:t>Script</a:t>
+            </a:r>
+            <a:r>
+              <a:rPr/>
+              <a:t> </a:t>
+            </a:r>
+            <a:r>
+              <a:rPr/>
+              <a:t>(Oral</a:t>
+            </a:r>
+            <a:r>
+              <a:rPr/>
+              <a:t> </a:t>
+            </a:r>
+            <a:r>
+              <a:rPr/>
+              <a:t>Exam)</a:t>
             </a:r>
           </a:p>
         </p:txBody>
@@ -3250,24 +3283,57 @@
           <a:bodyPr/>
           <a:lstStyle/>
           <a:p>
-            <a:pPr lvl="1"/>
-            <a:r>
-              <a:rPr/>
-              <a:t>Timezone accuracy</a:t>
-            </a:r>
-          </a:p>
-          <a:p>
-            <a:pPr lvl="1"/>
-            <a:r>
-              <a:rPr/>
-              <a:t>Noisy trend sentiment</a:t>
-            </a:r>
-          </a:p>
-          <a:p>
-            <a:pPr lvl="1"/>
-            <a:r>
-              <a:rPr/>
-              <a:t>External data reliability</a:t>
+            <a:pPr lvl="1">
+              <a:buAutoNum type="arabicPeriod"/>
+            </a:pPr>
+            <a:r>
+              <a:rPr/>
+              <a:t>Register/login and obtain JWT</a:t>
+            </a:r>
+          </a:p>
+          <a:p>
+            <a:pPr lvl="1">
+              <a:buAutoNum type="arabicPeriod"/>
+            </a:pPr>
+            <a:r>
+              <a:rPr/>
+              <a:t>Create item + outfit</a:t>
+            </a:r>
+          </a:p>
+          <a:p>
+            <a:pPr lvl="1">
+              <a:buAutoNum type="arabicPeriod"/>
+            </a:pPr>
+            <a:r>
+              <a:rPr/>
+              <a:t>Request recommendation for a specific location/time</a:t>
+            </a:r>
+          </a:p>
+          <a:p>
+            <a:pPr lvl="1">
+              <a:buAutoNum type="arabicPeriod"/>
+            </a:pPr>
+            <a:r>
+              <a:rPr/>
+              <a:t>Inspect score breakdown (weather + trend + feedback effects)</a:t>
+            </a:r>
+          </a:p>
+          <a:p>
+            <a:pPr lvl="1">
+              <a:buAutoNum type="arabicPeriod"/>
+            </a:pPr>
+            <a:r>
+              <a:rPr/>
+              <a:t>Submit feedback and re-query to show adaptive change</a:t>
+            </a:r>
+          </a:p>
+          <a:p>
+            <a:pPr lvl="1">
+              <a:buAutoNum type="arabicPeriod"/>
+            </a:pPr>
+            <a:r>
+              <a:rPr/>
+              <a:t>Use chat recommendation for constrained scenario refinement</a:t>
             </a:r>
           </a:p>
         </p:txBody>
@@ -3314,7 +3380,7 @@
             </a:pPr>
             <a:r>
               <a:rPr/>
-              <a:t>Future</a:t>
+              <a:t>Limitations</a:t>
             </a:r>
             <a:r>
               <a:rPr/>
@@ -3322,7 +3388,31 @@
             </a:r>
             <a:r>
               <a:rPr/>
-              <a:t>Work</a:t>
+              <a:t>and</a:t>
+            </a:r>
+            <a:r>
+              <a:rPr/>
+              <a:t> </a:t>
+            </a:r>
+            <a:r>
+              <a:rPr/>
+              <a:t>Cutting-Edge</a:t>
+            </a:r>
+            <a:r>
+              <a:rPr/>
+              <a:t> </a:t>
+            </a:r>
+            <a:r>
+              <a:rPr/>
+              <a:t>Next</a:t>
+            </a:r>
+            <a:r>
+              <a:rPr/>
+              <a:t> </a:t>
+            </a:r>
+            <a:r>
+              <a:rPr/>
+              <a:t>Steps</a:t>
             </a:r>
           </a:p>
         </p:txBody>
@@ -3345,21 +3435,42 @@
             <a:pPr lvl="1"/>
             <a:r>
               <a:rPr/>
-              <a:t>Automated test suite</a:t>
+              <a:t>Current sentiment model is lexical and not multimodal</a:t>
             </a:r>
           </a:p>
           <a:p>
             <a:pPr lvl="1"/>
             <a:r>
               <a:rPr/>
-              <a:t>Job queue for trend ingestion</a:t>
+              <a:t>Personalization is bounded heuristic, not learned embeddings</a:t>
             </a:r>
           </a:p>
           <a:p>
             <a:pPr lvl="1"/>
             <a:r>
               <a:rPr/>
-              <a:t>Email delivery for daily digests</a:t>
+              <a:t>Next-stage roadmap:</a:t>
+            </a:r>
+          </a:p>
+          <a:p>
+            <a:pPr lvl="2"/>
+            <a:r>
+              <a:rPr/>
+              <a:t>Retrieval-augmented trend intelligence from richer sources</a:t>
+            </a:r>
+          </a:p>
+          <a:p>
+            <a:pPr lvl="2"/>
+            <a:r>
+              <a:rPr/>
+              <a:t>Lightweight learning-to-rank with explainability constraints</a:t>
+            </a:r>
+          </a:p>
+          <a:p>
+            <a:pPr lvl="2"/>
+            <a:r>
+              <a:rPr/>
+              <a:t>Counterfactual explanations: “why this outfit over the next best one?”</a:t>
             </a:r>
           </a:p>
         </p:txBody>
@@ -3406,7 +3517,7 @@
             </a:pPr>
             <a:r>
               <a:rPr/>
-              <a:t>Thank</a:t>
+              <a:t>Generative</a:t>
             </a:r>
             <a:r>
               <a:rPr/>
@@ -3414,7 +3525,39 @@
             </a:r>
             <a:r>
               <a:rPr/>
-              <a:t>You</a:t>
+              <a:t>AI</a:t>
+            </a:r>
+            <a:r>
+              <a:rPr/>
+              <a:t> </a:t>
+            </a:r>
+            <a:r>
+              <a:rPr/>
+              <a:t>Use</a:t>
+            </a:r>
+            <a:r>
+              <a:rPr/>
+              <a:t> </a:t>
+            </a:r>
+            <a:r>
+              <a:rPr/>
+              <a:t>(Transparent</a:t>
+            </a:r>
+            <a:r>
+              <a:rPr/>
+              <a:t> </a:t>
+            </a:r>
+            <a:r>
+              <a:rPr/>
+              <a:t>and</a:t>
+            </a:r>
+            <a:r>
+              <a:rPr/>
+              <a:t> </a:t>
+            </a:r>
+            <a:r>
+              <a:rPr/>
+              <a:t>Controlled)</a:t>
             </a:r>
           </a:p>
         </p:txBody>
@@ -3434,12 +3577,99 @@
           <a:bodyPr/>
           <a:lstStyle/>
           <a:p>
+            <a:pPr lvl="1"/>
+            <a:r>
+              <a:rPr/>
+              <a:t>Used for selective ideation, small code corrections, and document scaffolding</a:t>
+            </a:r>
+          </a:p>
+          <a:p>
+            <a:pPr lvl="1"/>
+            <a:r>
+              <a:rPr/>
+              <a:t>Final architecture, implementation, and validation decisions were human-led</a:t>
+            </a:r>
+          </a:p>
+          <a:p>
+            <a:pPr lvl="1"/>
+            <a:r>
+              <a:rPr/>
+              <a:t>Every suggestion was manually reviewed and tested before adoption</a:t>
+            </a:r>
+          </a:p>
+        </p:txBody>
+      </p:sp>
+    </p:spTree>
+  </p:cSld>
+</p:sld>
+</file>
+
+<file path=ppt/slides/slide13.xml><?xml version="1.0" encoding="utf-8"?>
+<p:sld xmlns:a="http://schemas.openxmlformats.org/drawingml/2006/main" xmlns:r="http://schemas.openxmlformats.org/officeDocument/2006/relationships" xmlns:p="http://schemas.openxmlformats.org/presentationml/2006/main">
+  <p:cSld>
+    <p:spTree>
+      <p:nvGrpSpPr>
+        <p:cNvPr id="1" name=""/>
+        <p:cNvGrpSpPr/>
+        <p:nvPr/>
+      </p:nvGrpSpPr>
+      <p:grpSpPr>
+        <a:xfrm>
+          <a:off x="0" y="0"/>
+          <a:ext cx="0" cy="0"/>
+          <a:chOff x="0" y="0"/>
+          <a:chExt cx="0" cy="0"/>
+        </a:xfrm>
+      </p:grpSpPr>
+      <p:sp>
+        <p:nvSpPr>
+          <p:cNvPr id="2" name="Title 1"/>
+          <p:cNvSpPr>
+            <a:spLocks noGrp="1"/>
+          </p:cNvSpPr>
+          <p:nvPr>
+            <p:ph type="title"/>
+          </p:nvPr>
+        </p:nvSpPr>
+        <p:spPr/>
+        <p:txBody>
+          <a:bodyPr/>
+          <a:lstStyle/>
+          <a:p>
             <a:pPr lvl="0" marL="0" indent="0">
               <a:buNone/>
             </a:pPr>
             <a:r>
               <a:rPr/>
-              <a:t>Questions?</a:t>
+              <a:t>Closing</a:t>
+            </a:r>
+          </a:p>
+        </p:txBody>
+      </p:sp>
+      <p:sp>
+        <p:nvSpPr>
+          <p:cNvPr id="3" name="Content Placeholder 2"/>
+          <p:cNvSpPr>
+            <a:spLocks noGrp="1"/>
+          </p:cNvSpPr>
+          <p:nvPr>
+            <p:ph idx="1"/>
+          </p:nvPr>
+        </p:nvSpPr>
+        <p:spPr/>
+        <p:txBody>
+          <a:bodyPr/>
+          <a:lstStyle/>
+          <a:p>
+            <a:pPr lvl="0" marL="0" indent="0">
+              <a:spcBef>
+                <a:spcPts val="3000"/>
+              </a:spcBef>
+              <a:buNone/>
+            </a:pPr>
+            <a:r>
+              <a:rPr b="1"/>
+              <a:t>Style Forecast demonstrates explainable, research-led innovation for real-world circular fashion decisions.</a:t>
             </a:r>
           </a:p>
         </p:txBody>
@@ -3522,28 +3752,28 @@
             </a:pPr>
             <a:r>
               <a:rPr b="1"/>
-              <a:t>Weather × Trends Outfit Recommendations</a:t>
+              <a:t>Climate Intelligence for Circular Fashion Decisions</a:t>
             </a:r>
           </a:p>
           <a:p>
             <a:pPr lvl="1"/>
             <a:r>
               <a:rPr/>
-              <a:t>Climate-aware outfit suggestions</a:t>
+              <a:t>From static outfit picks to context-aware, explainable recommendations</a:t>
             </a:r>
           </a:p>
           <a:p>
             <a:pPr lvl="1"/>
             <a:r>
               <a:rPr/>
-              <a:t>Trend-aware scoring from fashion media</a:t>
+              <a:t>Integrates weather forecasting, trend sentiment, and user preference signals</a:t>
             </a:r>
           </a:p>
           <a:p>
             <a:pPr lvl="1"/>
             <a:r>
               <a:rPr/>
-              <a:t>Adaptive feedback + chat assistant</a:t>
+              <a:t>Designed for practical reuse workflows: wear, swap, rent, recycle</a:t>
             </a:r>
           </a:p>
         </p:txBody>
@@ -3590,7 +3820,23 @@
             </a:pPr>
             <a:r>
               <a:rPr/>
-              <a:t>Problem</a:t>
+              <a:t>Why</a:t>
+            </a:r>
+            <a:r>
+              <a:rPr/>
+              <a:t> </a:t>
+            </a:r>
+            <a:r>
+              <a:rPr/>
+              <a:t>This</a:t>
+            </a:r>
+            <a:r>
+              <a:rPr/>
+              <a:t> </a:t>
+            </a:r>
+            <a:r>
+              <a:rPr/>
+              <a:t>Matters</a:t>
             </a:r>
           </a:p>
         </p:txBody>
@@ -3613,22 +3859,21 @@
             <a:pPr lvl="1"/>
             <a:r>
               <a:rPr/>
-              <a:t>Outfit choices depend on weather, trends, and personal context</a:t>
+              <a:t>Fashion assistants are often style-only and ignore climate risk</a:t>
             </a:r>
           </a:p>
           <a:p>
             <a:pPr lvl="1"/>
             <a:r>
               <a:rPr/>
-              <a:t>Existing apps don’t explain </a:t>
-            </a:r>
-            <a:r>
-              <a:rPr i="1"/>
-              <a:t>why</a:t>
-            </a:r>
-            <a:r>
-              <a:rPr/>
-              <a:t> a look is recommended</a:t>
+              <a:t>Sustainability platforms are often logistics-only and ignore user adoption</a:t>
+            </a:r>
+          </a:p>
+          <a:p>
+            <a:pPr lvl="1"/>
+            <a:r>
+              <a:rPr/>
+              <a:t>Recommendation systems often optimize accuracy, not explainability</a:t>
             </a:r>
           </a:p>
         </p:txBody>
@@ -3675,7 +3920,15 @@
             </a:pPr>
             <a:r>
               <a:rPr/>
-              <a:t>Solution</a:t>
+              <a:t>Core</a:t>
+            </a:r>
+            <a:r>
+              <a:rPr/>
+              <a:t> </a:t>
+            </a:r>
+            <a:r>
+              <a:rPr/>
+              <a:t>Innovation</a:t>
             </a:r>
           </a:p>
         </p:txBody>
@@ -3698,21 +3951,42 @@
             <a:pPr lvl="1"/>
             <a:r>
               <a:rPr/>
-              <a:t>API-first system that scores outfits using weather + trend signals</a:t>
+              <a:t>A single scoring pipeline combining:</a:t>
+            </a:r>
+          </a:p>
+          <a:p>
+            <a:pPr lvl="2"/>
+            <a:r>
+              <a:rPr/>
+              <a:t>Hourly weather suitability (temperature, precipitation, wind)</a:t>
+            </a:r>
+          </a:p>
+          <a:p>
+            <a:pPr lvl="2"/>
+            <a:r>
+              <a:rPr/>
+              <a:t>Trend momentum and sentiment from recent fashion media</a:t>
+            </a:r>
+          </a:p>
+          <a:p>
+            <a:pPr lvl="2"/>
+            <a:r>
+              <a:rPr/>
+              <a:t>Personal feedback adaptation over time</a:t>
             </a:r>
           </a:p>
           <a:p>
             <a:pPr lvl="1"/>
             <a:r>
               <a:rPr/>
-              <a:t>Chat assistant for richer constraints (occasion, activity, preferences)</a:t>
+              <a:t>Every recommendation includes interpretable score components</a:t>
             </a:r>
           </a:p>
           <a:p>
             <a:pPr lvl="1"/>
             <a:r>
               <a:rPr/>
-              <a:t>Save outfits and track usage to improve recommendations</a:t>
+              <a:t>Chat intent acts as a soft constraint, not a black-box override</a:t>
             </a:r>
           </a:p>
         </p:txBody>
@@ -3759,7 +4033,31 @@
             </a:pPr>
             <a:r>
               <a:rPr/>
-              <a:t>Architecture</a:t>
+              <a:t>Research</a:t>
+            </a:r>
+            <a:r>
+              <a:rPr/>
+              <a:t> </a:t>
+            </a:r>
+            <a:r>
+              <a:rPr/>
+              <a:t>Curiosity:</a:t>
+            </a:r>
+            <a:r>
+              <a:rPr/>
+              <a:t> </a:t>
+            </a:r>
+            <a:r>
+              <a:rPr/>
+              <a:t>Alternatives</a:t>
+            </a:r>
+            <a:r>
+              <a:rPr/>
+              <a:t> </a:t>
+            </a:r>
+            <a:r>
+              <a:rPr/>
+              <a:t>Explored</a:t>
             </a:r>
           </a:p>
         </p:txBody>
@@ -3782,35 +4080,28 @@
             <a:pPr lvl="1"/>
             <a:r>
               <a:rPr/>
-              <a:t>Client: React + Vite</a:t>
+              <a:t>Pure collaborative filtering: rejected (cold-start, sparse implicit signals)</a:t>
             </a:r>
           </a:p>
           <a:p>
             <a:pPr lvl="1"/>
             <a:r>
               <a:rPr/>
-              <a:t>API: NestJS + Prisma</a:t>
+              <a:t>End-to-end LLM ranking: rejected (non-deterministic and hard to audit)</a:t>
             </a:r>
           </a:p>
           <a:p>
             <a:pPr lvl="1"/>
             <a:r>
               <a:rPr/>
-              <a:t>Database: PostgreSQL</a:t>
+              <a:t>Chosen approach: hybrid heuristic + live data + bounded personalization</a:t>
             </a:r>
           </a:p>
           <a:p>
             <a:pPr lvl="1"/>
             <a:r>
               <a:rPr/>
-              <a:t>Weather: Open-Meteo</a:t>
-            </a:r>
-          </a:p>
-          <a:p>
-            <a:pPr lvl="1"/>
-            <a:r>
-              <a:rPr/>
-              <a:t>Trends: RSS keyword + sentiment</a:t>
+              <a:t>Rationale: stable outputs, transparent trade-offs, demo reliability</a:t>
             </a:r>
           </a:p>
         </p:txBody>
@@ -3857,6 +4148,14 @@
             </a:pPr>
             <a:r>
               <a:rPr/>
+              <a:t>Novel</a:t>
+            </a:r>
+            <a:r>
+              <a:rPr/>
+              <a:t> </a:t>
+            </a:r>
+            <a:r>
+              <a:rPr/>
               <a:t>Data</a:t>
             </a:r>
             <a:r>
@@ -3865,7 +4164,7 @@
             </a:r>
             <a:r>
               <a:rPr/>
-              <a:t>Model</a:t>
+              <a:t>Integration</a:t>
             </a:r>
           </a:p>
         </p:txBody>
@@ -3888,35 +4187,28 @@
             <a:pPr lvl="1"/>
             <a:r>
               <a:rPr/>
-              <a:t>User + Profile (home location, preferences)</a:t>
+              <a:t>Live Open-Meteo forecast + geocoding timezone resolution</a:t>
             </a:r>
           </a:p>
           <a:p>
             <a:pPr lvl="1"/>
             <a:r>
               <a:rPr/>
-              <a:t>Outfit + OutfitUsage</a:t>
+              <a:t>RSS-derived trend extraction with recency window (last 60 days)</a:t>
             </a:r>
           </a:p>
           <a:p>
             <a:pPr lvl="1"/>
             <a:r>
               <a:rPr/>
-              <a:t>ClimateSnapshot</a:t>
+              <a:t>Outfit usage logging with captured weather context</a:t>
             </a:r>
           </a:p>
           <a:p>
             <a:pPr lvl="1"/>
             <a:r>
               <a:rPr/>
-              <a:t>SocialTrend + TrendSignal</a:t>
-            </a:r>
-          </a:p>
-          <a:p>
-            <a:pPr lvl="1"/>
-            <a:r>
-              <a:rPr/>
-              <a:t>Feedback</a:t>
+              <a:t>Feedback memory to adapt subsequent ranking decisions</a:t>
             </a:r>
           </a:p>
         </p:txBody>
@@ -3963,7 +4255,7 @@
             </a:pPr>
             <a:r>
               <a:rPr/>
-              <a:t>Recommendation</a:t>
+              <a:t>System</a:t>
             </a:r>
             <a:r>
               <a:rPr/>
@@ -3971,7 +4263,7 @@
             </a:r>
             <a:r>
               <a:rPr/>
-              <a:t>Logic</a:t>
+              <a:t>Architecture</a:t>
             </a:r>
           </a:p>
         </p:txBody>
@@ -3994,28 +4286,35 @@
             <a:pPr lvl="1"/>
             <a:r>
               <a:rPr/>
-              <a:t>Temperature fit + wind/precip penalties</a:t>
+              <a:t>Frontend: React + Vite (interactive recommendation and chat UX)</a:t>
             </a:r>
           </a:p>
           <a:p>
             <a:pPr lvl="1"/>
             <a:r>
               <a:rPr/>
-              <a:t>Trend boost from recent media sentiment</a:t>
+              <a:t>Backend: NestJS modular services</a:t>
             </a:r>
           </a:p>
           <a:p>
             <a:pPr lvl="1"/>
             <a:r>
               <a:rPr/>
-              <a:t>User feedback bias</a:t>
+              <a:t>Data layer: Prisma + PostgreSQL</a:t>
             </a:r>
           </a:p>
           <a:p>
             <a:pPr lvl="1"/>
             <a:r>
               <a:rPr/>
-              <a:t>Chat intent bias (occasion/avoid tags)</a:t>
+              <a:t>Auth: JWT access + refresh token lifecycle</a:t>
+            </a:r>
+          </a:p>
+          <a:p>
+            <a:pPr lvl="1"/>
+            <a:r>
+              <a:rPr/>
+              <a:t>API docs via OpenAPI/Swagger for reproducible integration</a:t>
             </a:r>
           </a:p>
         </p:txBody>
@@ -4062,7 +4361,7 @@
             </a:pPr>
             <a:r>
               <a:rPr/>
-              <a:t>Live</a:t>
+              <a:t>Scoring</a:t>
             </a:r>
             <a:r>
               <a:rPr/>
@@ -4070,7 +4369,7 @@
             </a:r>
             <a:r>
               <a:rPr/>
-              <a:t>Demo</a:t>
+              <a:t>Design</a:t>
             </a:r>
             <a:r>
               <a:rPr/>
@@ -4078,7 +4377,15 @@
             </a:r>
             <a:r>
               <a:rPr/>
-              <a:t>Flow</a:t>
+              <a:t>(Expert-Level</a:t>
+            </a:r>
+            <a:r>
+              <a:rPr/>
+              <a:t> </a:t>
+            </a:r>
+            <a:r>
+              <a:rPr/>
+              <a:t>View)</a:t>
             </a:r>
           </a:p>
         </p:txBody>
@@ -4098,39 +4405,66 @@
           <a:bodyPr/>
           <a:lstStyle/>
           <a:p>
-            <a:pPr lvl="1">
-              <a:buAutoNum type="arabicPeriod"/>
-            </a:pPr>
-            <a:r>
-              <a:rPr/>
-              <a:t>Select location + time</a:t>
-            </a:r>
-          </a:p>
-          <a:p>
-            <a:pPr lvl="1">
-              <a:buAutoNum type="arabicPeriod"/>
-            </a:pPr>
-            <a:r>
-              <a:rPr/>
-              <a:t>Generate recommendation</a:t>
-            </a:r>
-          </a:p>
-          <a:p>
-            <a:pPr lvl="1">
-              <a:buAutoNum type="arabicPeriod"/>
-            </a:pPr>
-            <a:r>
-              <a:rPr/>
-              <a:t>Save outfit</a:t>
-            </a:r>
-          </a:p>
-          <a:p>
-            <a:pPr lvl="1">
-              <a:buAutoNum type="arabicPeriod"/>
-            </a:pPr>
-            <a:r>
-              <a:rPr/>
-              <a:t>Open chat for tailored advice</a:t>
+            <a:pPr lvl="1"/>
+            <a:r>
+              <a:rPr/>
+              <a:t>Base utility = weighted blend of:</a:t>
+            </a:r>
+          </a:p>
+          <a:p>
+            <a:pPr lvl="2"/>
+            <a:r>
+              <a:rPr/>
+              <a:t>Thermal comfort fit</a:t>
+            </a:r>
+          </a:p>
+          <a:p>
+            <a:pPr lvl="2"/>
+            <a:r>
+              <a:rPr/>
+              <a:t>Rain and wind resilience</a:t>
+            </a:r>
+          </a:p>
+          <a:p>
+            <a:pPr lvl="2"/>
+            <a:r>
+              <a:rPr/>
+              <a:t>Trend relevance boost</a:t>
+            </a:r>
+          </a:p>
+          <a:p>
+            <a:pPr lvl="2"/>
+            <a:r>
+              <a:rPr/>
+              <a:t>User-adaptive confidence bonus</a:t>
+            </a:r>
+          </a:p>
+          <a:p>
+            <a:pPr lvl="1"/>
+            <a:r>
+              <a:rPr/>
+              <a:t>Guardrails:</a:t>
+            </a:r>
+          </a:p>
+          <a:p>
+            <a:pPr lvl="2"/>
+            <a:r>
+              <a:rPr/>
+              <a:t>Penalties for weather-incompatible materials/tags</a:t>
+            </a:r>
+          </a:p>
+          <a:p>
+            <a:pPr lvl="2"/>
+            <a:r>
+              <a:rPr/>
+              <a:t>Bounded boosts to prevent unstable ranking swings</a:t>
+            </a:r>
+          </a:p>
+          <a:p>
+            <a:pPr lvl="1"/>
+            <a:r>
+              <a:rPr/>
+              <a:t>Outcome: robust and explainable recommendations under noisy inputs</a:t>
             </a:r>
           </a:p>
         </p:txBody>
@@ -4177,8 +4511,32 @@
             </a:pPr>
             <a:r>
               <a:rPr/>
+              <a:t>Quality</a:t>
+            </a:r>
+            <a:r>
+              <a:rPr/>
+              <a:t> </a:t>
+            </a:r>
+            <a:r>
+              <a:rPr/>
+              <a:t>and</a:t>
+            </a:r>
+            <a:r>
+              <a:rPr/>
+              <a:t> </a:t>
+            </a:r>
+            <a:r>
+              <a:rPr/>
               <a:t>Evaluation</a:t>
             </a:r>
+            <a:r>
+              <a:rPr/>
+              <a:t> </a:t>
+            </a:r>
+            <a:r>
+              <a:rPr/>
+              <a:t>Strategy</a:t>
+            </a:r>
           </a:p>
         </p:txBody>
       </p:sp>
@@ -4200,28 +4558,35 @@
             <a:pPr lvl="1"/>
             <a:r>
               <a:rPr/>
-              <a:t>Weather/timezone correctness</a:t>
+              <a:t>Functional correctness: end-to-end API + UI flows</a:t>
             </a:r>
           </a:p>
           <a:p>
             <a:pPr lvl="1"/>
             <a:r>
               <a:rPr/>
-              <a:t>Trend recency (last 60 days)</a:t>
+              <a:t>Robustness: timezone conversion and nearest-hour weather matching</a:t>
             </a:r>
           </a:p>
           <a:p>
             <a:pPr lvl="1"/>
             <a:r>
               <a:rPr/>
-              <a:t>Explainability in responses</a:t>
+              <a:t>Relevance: trend recency filtering and sentiment weighting</a:t>
             </a:r>
           </a:p>
           <a:p>
             <a:pPr lvl="1"/>
             <a:r>
               <a:rPr/>
-              <a:t>Feedback improves personalization</a:t>
+              <a:t>Explainability: item-level and outfit-level score decomposition</a:t>
+            </a:r>
+          </a:p>
+          <a:p>
+            <a:pPr lvl="1"/>
+            <a:r>
+              <a:rPr/>
+              <a:t>Delivery quality: reproducible setup, documented endpoints, runnable build</a:t>
             </a:r>
           </a:p>
         </p:txBody>

</xml_diff>